<commit_message>
Update OPC, PropertyBreak, Package
</commit_message>
<xml_diff>
--- a/ContinuationProject/ContentTeam/PropertyBreak.pptx
+++ b/ContinuationProject/ContentTeam/PropertyBreak.pptx
@@ -226,7 +226,7 @@
             <a:fld id="{4AA9FAFC-2319-504C-A7E6-C27BB7BBEBBC}" type="datetimeFigureOut">
               <a:rPr lang="mr-IN"/>
               <a:pPr/>
-              <a:t>17-11-2025</a:t>
+              <a:t>25-11-2025</a:t>
             </a:fld>
             <a:endParaRPr lang="mr-IN"/>
           </a:p>
@@ -1266,7 +1266,7 @@
             <a:fld id="{C8927868-526A-4C6B-96A5-2F672AB9D3F4}" type="datetimeFigureOut">
               <a:rPr lang="en-US" smtClean="0"/>
               <a:pPr/>
-              <a:t>11/17/2025</a:t>
+              <a:t>11/25/2025</a:t>
             </a:fld>
             <a:endParaRPr lang="en-US"/>
           </a:p>
@@ -4655,10 +4655,10 @@
       </p:grpSpPr>
       <p:pic>
         <p:nvPicPr>
-          <p:cNvPr id="13" name="Picture 12">
+          <p:cNvPr id="8" name="Picture 7" descr="A screenshot of a computer&#10;&#10;AI-generated content may be incorrect.">
             <a:extLst>
               <a:ext uri="{FF2B5EF4-FFF2-40B4-BE49-F238E27FC236}">
-                <a16:creationId xmlns:a16="http://schemas.microsoft.com/office/drawing/2014/main" id="{5FE7289C-6A6B-F858-A6F0-ADBED22F9E7E}"/>
+                <a16:creationId xmlns:a16="http://schemas.microsoft.com/office/drawing/2014/main" id="{F9DBE38E-40A3-F42F-1DF2-7DCF3F9A7EC1}"/>
               </a:ext>
             </a:extLst>
           </p:cNvPr>
@@ -4675,8 +4675,8 @@
         </p:blipFill>
         <p:spPr>
           <a:xfrm>
-            <a:off x="3612453" y="867401"/>
-            <a:ext cx="4990417" cy="4106542"/>
+            <a:off x="3526088" y="742950"/>
+            <a:ext cx="5259627" cy="4289656"/>
           </a:xfrm>
           <a:prstGeom prst="rect">
             <a:avLst/>

</xml_diff>

<commit_message>
push customequipmentpackage & propertybreak & status
</commit_message>
<xml_diff>
--- a/ContinuationProject/ContentTeam/PropertyBreak.pptx
+++ b/ContinuationProject/ContentTeam/PropertyBreak.pptx
@@ -226,7 +226,7 @@
             <a:fld id="{4AA9FAFC-2319-504C-A7E6-C27BB7BBEBBC}" type="datetimeFigureOut">
               <a:rPr lang="mr-IN"/>
               <a:pPr/>
-              <a:t>25-11-2025</a:t>
+              <a:t>01-12-2025</a:t>
             </a:fld>
             <a:endParaRPr lang="mr-IN"/>
           </a:p>
@@ -1266,7 +1266,7 @@
             <a:fld id="{C8927868-526A-4C6B-96A5-2F672AB9D3F4}" type="datetimeFigureOut">
               <a:rPr lang="en-US" smtClean="0"/>
               <a:pPr/>
-              <a:t>11/25/2025</a:t>
+              <a:t>12/1/2025</a:t>
             </a:fld>
             <a:endParaRPr lang="en-US"/>
           </a:p>
@@ -4655,10 +4655,10 @@
       </p:grpSpPr>
       <p:pic>
         <p:nvPicPr>
-          <p:cNvPr id="8" name="Picture 7" descr="A screenshot of a computer&#10;&#10;AI-generated content may be incorrect.">
+          <p:cNvPr id="4" name="Picture 3" descr="A diagram of a computer&#10;&#10;AI-generated content may be incorrect.">
             <a:extLst>
               <a:ext uri="{FF2B5EF4-FFF2-40B4-BE49-F238E27FC236}">
-                <a16:creationId xmlns:a16="http://schemas.microsoft.com/office/drawing/2014/main" id="{F9DBE38E-40A3-F42F-1DF2-7DCF3F9A7EC1}"/>
+                <a16:creationId xmlns:a16="http://schemas.microsoft.com/office/drawing/2014/main" id="{6422B29C-50A5-6F8A-6F86-D734F6E9ECC4}"/>
               </a:ext>
             </a:extLst>
           </p:cNvPr>
@@ -4675,8 +4675,8 @@
         </p:blipFill>
         <p:spPr>
           <a:xfrm>
-            <a:off x="3526088" y="742950"/>
-            <a:ext cx="5259627" cy="4289656"/>
+            <a:off x="3987038" y="974816"/>
+            <a:ext cx="4852162" cy="3882934"/>
           </a:xfrm>
           <a:prstGeom prst="rect">
             <a:avLst/>
@@ -4757,7 +4757,7 @@
             </a:r>
             <a:r>
               <a:rPr lang="en-US" dirty="0" err="1"/>
-              <a:t>BreakType</a:t>
+              <a:t>LogicalBreak</a:t>
             </a:r>
             <a:r>
               <a:rPr lang="en-US" dirty="0"/>
@@ -4892,10 +4892,10 @@
       </p:sp>
       <p:pic>
         <p:nvPicPr>
-          <p:cNvPr id="4" name="Picture 3">
+          <p:cNvPr id="5" name="Picture 4" descr="A diagram of a computer&#10;&#10;AI-generated content may be incorrect.">
             <a:extLst>
               <a:ext uri="{FF2B5EF4-FFF2-40B4-BE49-F238E27FC236}">
-                <a16:creationId xmlns:a16="http://schemas.microsoft.com/office/drawing/2014/main" id="{1C9F87B2-E9E7-650D-EB7A-971C4339E8DF}"/>
+                <a16:creationId xmlns:a16="http://schemas.microsoft.com/office/drawing/2014/main" id="{E49D046A-F6F4-2C5E-3527-F036E6F07809}"/>
               </a:ext>
             </a:extLst>
           </p:cNvPr>
@@ -4912,8 +4912,8 @@
         </p:blipFill>
         <p:spPr>
           <a:xfrm>
-            <a:off x="527315" y="827225"/>
-            <a:ext cx="6357935" cy="4030525"/>
+            <a:off x="358651" y="1005839"/>
+            <a:ext cx="6656828" cy="3704427"/>
           </a:xfrm>
           <a:prstGeom prst="rect">
             <a:avLst/>

</xml_diff>